<commit_message>
Ajout de Rapport et modification de presentation
</commit_message>
<xml_diff>
--- a/ISET_Formation.pptx
+++ b/ISET_Formation.pptx
@@ -1620,7 +1620,249 @@
           <a:bodyPr/>
           <a:lstStyle/>
           <a:p>
-            <a:endParaRPr lang="en-US"/>
+            <a:endParaRPr lang="en-US" dirty="0">
+              <a:solidFill>
+                <a:srgbClr val="FFFFFF"/>
+              </a:solidFill>
+              <a:latin typeface="Calibri" pitchFamily="34" charset="0"/>
+              <a:ea typeface="Calibri" pitchFamily="34" charset="-122"/>
+              <a:cs typeface="Calibri" pitchFamily="34" charset="-120"/>
+            </a:endParaRPr>
+          </a:p>
+          <a:p>
+            <a:endParaRPr lang="en-US" dirty="0">
+              <a:solidFill>
+                <a:srgbClr val="FFFFFF"/>
+              </a:solidFill>
+              <a:latin typeface="Calibri" pitchFamily="34" charset="0"/>
+              <a:ea typeface="Calibri" pitchFamily="34" charset="-122"/>
+              <a:cs typeface="Calibri" pitchFamily="34" charset="-120"/>
+            </a:endParaRPr>
+          </a:p>
+          <a:p>
+            <a:r>
+              <a:rPr lang="en-US" dirty="0" err="1">
+                <a:solidFill>
+                  <a:srgbClr val="FFFFFF"/>
+                </a:solidFill>
+                <a:latin typeface="Calibri" pitchFamily="34" charset="0"/>
+                <a:ea typeface="Calibri" pitchFamily="34" charset="-122"/>
+                <a:cs typeface="Calibri" pitchFamily="34" charset="-120"/>
+              </a:rPr>
+              <a:t>Réalisé</a:t>
+            </a:r>
+            <a:r>
+              <a:rPr lang="en-US" dirty="0">
+                <a:solidFill>
+                  <a:srgbClr val="FFFFFF"/>
+                </a:solidFill>
+                <a:latin typeface="Calibri" pitchFamily="34" charset="0"/>
+                <a:ea typeface="Calibri" pitchFamily="34" charset="-122"/>
+                <a:cs typeface="Calibri" pitchFamily="34" charset="-120"/>
+              </a:rPr>
+              <a:t> par :</a:t>
+            </a:r>
+          </a:p>
+          <a:p>
+            <a:endParaRPr lang="en-US" dirty="0">
+              <a:solidFill>
+                <a:srgbClr val="FFFFFF"/>
+              </a:solidFill>
+              <a:latin typeface="Calibri" pitchFamily="34" charset="0"/>
+              <a:ea typeface="Calibri" pitchFamily="34" charset="-122"/>
+              <a:cs typeface="Calibri" pitchFamily="34" charset="-120"/>
+            </a:endParaRPr>
+          </a:p>
+          <a:p>
+            <a:endParaRPr lang="en-US" dirty="0">
+              <a:solidFill>
+                <a:srgbClr val="FFFFFF"/>
+              </a:solidFill>
+              <a:latin typeface="Calibri" pitchFamily="34" charset="0"/>
+              <a:ea typeface="Calibri" pitchFamily="34" charset="-122"/>
+              <a:cs typeface="Calibri" pitchFamily="34" charset="-120"/>
+            </a:endParaRPr>
+          </a:p>
+          <a:p>
+            <a:endParaRPr lang="en-US" dirty="0">
+              <a:solidFill>
+                <a:srgbClr val="FFFFFF"/>
+              </a:solidFill>
+              <a:latin typeface="Calibri" pitchFamily="34" charset="0"/>
+              <a:ea typeface="Calibri" pitchFamily="34" charset="-122"/>
+              <a:cs typeface="Calibri" pitchFamily="34" charset="-120"/>
+            </a:endParaRPr>
+          </a:p>
+          <a:p>
+            <a:endParaRPr lang="en-US" dirty="0">
+              <a:solidFill>
+                <a:srgbClr val="FFFFFF"/>
+              </a:solidFill>
+              <a:latin typeface="Calibri" pitchFamily="34" charset="0"/>
+              <a:ea typeface="Calibri" pitchFamily="34" charset="-122"/>
+              <a:cs typeface="Calibri" pitchFamily="34" charset="-120"/>
+            </a:endParaRPr>
+          </a:p>
+          <a:p>
+            <a:endParaRPr lang="en-US" dirty="0">
+              <a:solidFill>
+                <a:srgbClr val="FFFFFF"/>
+              </a:solidFill>
+              <a:latin typeface="Calibri" pitchFamily="34" charset="0"/>
+              <a:ea typeface="Calibri" pitchFamily="34" charset="-122"/>
+              <a:cs typeface="Calibri" pitchFamily="34" charset="-120"/>
+            </a:endParaRPr>
+          </a:p>
+          <a:p>
+            <a:endParaRPr lang="en-US" dirty="0">
+              <a:solidFill>
+                <a:srgbClr val="FFFFFF"/>
+              </a:solidFill>
+              <a:latin typeface="Calibri" pitchFamily="34" charset="0"/>
+              <a:ea typeface="Calibri" pitchFamily="34" charset="-122"/>
+              <a:cs typeface="Calibri" pitchFamily="34" charset="-120"/>
+            </a:endParaRPr>
+          </a:p>
+          <a:p>
+            <a:r>
+              <a:rPr lang="en-US" b="1" dirty="0">
+                <a:solidFill>
+                  <a:srgbClr val="FFFFFF"/>
+                </a:solidFill>
+                <a:latin typeface="Calibri" pitchFamily="34" charset="0"/>
+                <a:ea typeface="Calibri" pitchFamily="34" charset="-122"/>
+                <a:cs typeface="Calibri" pitchFamily="34" charset="-120"/>
+              </a:rPr>
+              <a:t>          Riabi </a:t>
+            </a:r>
+            <a:r>
+              <a:rPr lang="en-US" b="1" dirty="0" err="1">
+                <a:solidFill>
+                  <a:srgbClr val="FFFFFF"/>
+                </a:solidFill>
+                <a:latin typeface="Calibri" pitchFamily="34" charset="0"/>
+                <a:ea typeface="Calibri" pitchFamily="34" charset="-122"/>
+                <a:cs typeface="Calibri" pitchFamily="34" charset="-120"/>
+              </a:rPr>
+              <a:t>Yassemine</a:t>
+            </a:r>
+            <a:endParaRPr lang="en-US" b="1" dirty="0">
+              <a:solidFill>
+                <a:srgbClr val="FFFFFF"/>
+              </a:solidFill>
+              <a:latin typeface="Calibri" pitchFamily="34" charset="0"/>
+              <a:ea typeface="Calibri" pitchFamily="34" charset="-122"/>
+              <a:cs typeface="Calibri" pitchFamily="34" charset="-120"/>
+            </a:endParaRPr>
+          </a:p>
+          <a:p>
+            <a:endParaRPr lang="en-US" b="1" dirty="0">
+              <a:solidFill>
+                <a:srgbClr val="FFFFFF"/>
+              </a:solidFill>
+              <a:latin typeface="Calibri" pitchFamily="34" charset="0"/>
+              <a:ea typeface="Calibri" pitchFamily="34" charset="-122"/>
+              <a:cs typeface="Calibri" pitchFamily="34" charset="-120"/>
+            </a:endParaRPr>
+          </a:p>
+          <a:p>
+            <a:endParaRPr lang="en-US" b="1" dirty="0">
+              <a:solidFill>
+                <a:srgbClr val="FFFFFF"/>
+              </a:solidFill>
+              <a:latin typeface="Calibri" pitchFamily="34" charset="0"/>
+              <a:ea typeface="Calibri" pitchFamily="34" charset="-122"/>
+              <a:cs typeface="Calibri" pitchFamily="34" charset="-120"/>
+            </a:endParaRPr>
+          </a:p>
+          <a:p>
+            <a:endParaRPr lang="en-US" b="1" dirty="0">
+              <a:solidFill>
+                <a:srgbClr val="FFFFFF"/>
+              </a:solidFill>
+              <a:latin typeface="Calibri" pitchFamily="34" charset="0"/>
+              <a:ea typeface="Calibri" pitchFamily="34" charset="-122"/>
+              <a:cs typeface="Calibri" pitchFamily="34" charset="-120"/>
+            </a:endParaRPr>
+          </a:p>
+          <a:p>
+            <a:endParaRPr lang="en-US" b="1" dirty="0">
+              <a:solidFill>
+                <a:srgbClr val="FFFFFF"/>
+              </a:solidFill>
+              <a:latin typeface="Calibri" pitchFamily="34" charset="0"/>
+              <a:ea typeface="Calibri" pitchFamily="34" charset="-122"/>
+              <a:cs typeface="Calibri" pitchFamily="34" charset="-120"/>
+            </a:endParaRPr>
+          </a:p>
+          <a:p>
+            <a:endParaRPr lang="en-US" b="1" dirty="0">
+              <a:solidFill>
+                <a:srgbClr val="FFFFFF"/>
+              </a:solidFill>
+              <a:latin typeface="Calibri" pitchFamily="34" charset="0"/>
+              <a:ea typeface="Calibri" pitchFamily="34" charset="-122"/>
+              <a:cs typeface="Calibri" pitchFamily="34" charset="-120"/>
+            </a:endParaRPr>
+          </a:p>
+          <a:p>
+            <a:r>
+              <a:rPr lang="en-US" b="1" dirty="0">
+                <a:solidFill>
+                  <a:srgbClr val="FFFFFF"/>
+                </a:solidFill>
+                <a:latin typeface="Calibri" pitchFamily="34" charset="0"/>
+                <a:ea typeface="Calibri" pitchFamily="34" charset="-122"/>
+                <a:cs typeface="Calibri" pitchFamily="34" charset="-120"/>
+              </a:rPr>
+              <a:t>         </a:t>
+            </a:r>
+          </a:p>
+          <a:p>
+            <a:endParaRPr lang="en-US" b="1" dirty="0">
+              <a:solidFill>
+                <a:srgbClr val="FFFFFF"/>
+              </a:solidFill>
+              <a:latin typeface="Calibri" pitchFamily="34" charset="0"/>
+              <a:ea typeface="Calibri" pitchFamily="34" charset="-122"/>
+              <a:cs typeface="Calibri" pitchFamily="34" charset="-120"/>
+            </a:endParaRPr>
+          </a:p>
+          <a:p>
+            <a:r>
+              <a:rPr lang="en-US" b="1" dirty="0">
+                <a:solidFill>
+                  <a:srgbClr val="FFFFFF"/>
+                </a:solidFill>
+                <a:latin typeface="Calibri" pitchFamily="34" charset="0"/>
+                <a:ea typeface="Calibri" pitchFamily="34" charset="-122"/>
+                <a:cs typeface="Calibri" pitchFamily="34" charset="-120"/>
+              </a:rPr>
+              <a:t>             </a:t>
+            </a:r>
+            <a:r>
+              <a:rPr lang="en-US" b="1" dirty="0" err="1">
+                <a:solidFill>
+                  <a:srgbClr val="FFFFFF"/>
+                </a:solidFill>
+                <a:latin typeface="Calibri" pitchFamily="34" charset="0"/>
+                <a:ea typeface="Calibri" pitchFamily="34" charset="-122"/>
+                <a:cs typeface="Calibri" pitchFamily="34" charset="-120"/>
+              </a:rPr>
+              <a:t>Weslati</a:t>
+            </a:r>
+            <a:r>
+              <a:rPr lang="en-US" b="1" dirty="0">
+                <a:solidFill>
+                  <a:srgbClr val="FFFFFF"/>
+                </a:solidFill>
+                <a:latin typeface="Calibri" pitchFamily="34" charset="0"/>
+                <a:ea typeface="Calibri" pitchFamily="34" charset="-122"/>
+                <a:cs typeface="Calibri" pitchFamily="34" charset="-120"/>
+              </a:rPr>
+              <a:t> Ameni</a:t>
+            </a:r>
+            <a:endParaRPr lang="en-US" dirty="0"/>
           </a:p>
         </p:txBody>
       </p:sp>
@@ -2003,7 +2245,7 @@
         </p:nvSpPr>
         <p:spPr>
           <a:xfrm>
-            <a:off x="0" y="1645920"/>
+            <a:off x="0" y="-351118"/>
             <a:ext cx="3017520" cy="1371600"/>
           </a:xfrm>
           <a:prstGeom prst="rect">
@@ -2595,6 +2837,66 @@
           </a:p>
         </p:txBody>
       </p:sp>
+      <p:pic>
+        <p:nvPicPr>
+          <p:cNvPr id="31" name="Picture 30">
+            <a:extLst>
+              <a:ext uri="{FF2B5EF4-FFF2-40B4-BE49-F238E27FC236}">
+                <a16:creationId xmlns:a16="http://schemas.microsoft.com/office/drawing/2014/main" id="{9A626BD9-04F6-5686-1796-6C47AC674661}"/>
+              </a:ext>
+            </a:extLst>
+          </p:cNvPr>
+          <p:cNvPicPr>
+            <a:picLocks noChangeAspect="1"/>
+          </p:cNvPicPr>
+          <p:nvPr/>
+        </p:nvPicPr>
+        <p:blipFill>
+          <a:blip r:embed="rId3"/>
+          <a:stretch>
+            <a:fillRect/>
+          </a:stretch>
+        </p:blipFill>
+        <p:spPr>
+          <a:xfrm>
+            <a:off x="354209" y="1020619"/>
+            <a:ext cx="1842597" cy="1229465"/>
+          </a:xfrm>
+          <a:prstGeom prst="rect">
+            <a:avLst/>
+          </a:prstGeom>
+        </p:spPr>
+      </p:pic>
+      <p:pic>
+        <p:nvPicPr>
+          <p:cNvPr id="35" name="Picture 34">
+            <a:extLst>
+              <a:ext uri="{FF2B5EF4-FFF2-40B4-BE49-F238E27FC236}">
+                <a16:creationId xmlns:a16="http://schemas.microsoft.com/office/drawing/2014/main" id="{F847D595-3C0B-E936-4944-71E4484DA10F}"/>
+              </a:ext>
+            </a:extLst>
+          </p:cNvPr>
+          <p:cNvPicPr>
+            <a:picLocks noChangeAspect="1"/>
+          </p:cNvPicPr>
+          <p:nvPr/>
+        </p:nvPicPr>
+        <p:blipFill>
+          <a:blip r:embed="rId4"/>
+          <a:stretch>
+            <a:fillRect/>
+          </a:stretch>
+        </p:blipFill>
+        <p:spPr>
+          <a:xfrm>
+            <a:off x="593188" y="3057589"/>
+            <a:ext cx="1217324" cy="1437765"/>
+          </a:xfrm>
+          <a:prstGeom prst="rect">
+            <a:avLst/>
+          </a:prstGeom>
+        </p:spPr>
+      </p:pic>
     </p:spTree>
   </p:cSld>
   <p:clrMapOvr>

</xml_diff>